<commit_message>
Correct lesson-deck spelling, grade chips and leftover English
Edit the text inside existing slides only. A data-only migration rewrites
a file on the media volume when its hash is still the old deck.

Co-authored-by: Amanov <isaamanov@gmail.com>
</commit_message>
<xml_diff>
--- a/apps/resources/bundled_files/1-klass-10-ichinde-kemituu-oyun-1234.pptx
+++ b/apps/resources/bundled_files/1-klass-10-ichinde-kemituu-oyun-1234.pptx
@@ -3781,7 +3781,7 @@
                 </a:solidFill>
                 <a:latin typeface="PT Sans"/>
               </a:rPr>
-              <a:t>1-класс ›</a:t>
+              <a:t/>
             </a:r>
           </a:p>
           <a:p>
@@ -4689,7 +4689,7 @@
                 </a:solidFill>
                 <a:latin typeface="PT Sans"/>
               </a:rPr>
-              <a:t>1-класс ›</a:t>
+              <a:t/>
             </a:r>
           </a:p>
           <a:p>
@@ -5631,7 +5631,7 @@
                 </a:solidFill>
                 <a:latin typeface="PT Sans"/>
               </a:rPr>
-              <a:t>1-класс ›</a:t>
+              <a:t/>
             </a:r>
           </a:p>
           <a:p>
@@ -6801,7 +6801,7 @@
                 </a:solidFill>
                 <a:latin typeface="PT Sans"/>
               </a:rPr>
-              <a:t>1-класс ›</a:t>
+              <a:t/>
             </a:r>
           </a:p>
           <a:p>
@@ -7743,7 +7743,7 @@
                 </a:solidFill>
                 <a:latin typeface="PT Sans"/>
               </a:rPr>
-              <a:t>1-класс ›</a:t>
+              <a:t/>
             </a:r>
           </a:p>
           <a:p>
@@ -8913,7 +8913,7 @@
                 </a:solidFill>
                 <a:latin typeface="PT Sans"/>
               </a:rPr>
-              <a:t>1-класс ›</a:t>
+              <a:t/>
             </a:r>
           </a:p>
           <a:p>
@@ -9855,7 +9855,7 @@
                 </a:solidFill>
                 <a:latin typeface="PT Sans"/>
               </a:rPr>
-              <a:t>1-класс ›</a:t>
+              <a:t/>
             </a:r>
           </a:p>
           <a:p>
@@ -11025,7 +11025,7 @@
                 </a:solidFill>
                 <a:latin typeface="PT Sans"/>
               </a:rPr>
-              <a:t>1-класс ›</a:t>
+              <a:t/>
             </a:r>
           </a:p>
           <a:p>
@@ -11967,7 +11967,7 @@
                 </a:solidFill>
                 <a:latin typeface="PT Sans"/>
               </a:rPr>
-              <a:t>1-класс ›</a:t>
+              <a:t/>
             </a:r>
           </a:p>
           <a:p>

</xml_diff>

<commit_message>
Correct spelling, grade chips and leftover English in lesson decks (#37)
Correct lesson-deck spelling, grade chips and leftover English

Edit the text inside existing slides only. A data-only migration rewrites
a file on the media volume when its hash is still the old deck.

Co-authored-by: Cursor Agent <cursoragent@cursor.com>
</commit_message>
<xml_diff>
--- a/apps/resources/bundled_files/1-klass-10-ichinde-kemituu-oyun-1234.pptx
+++ b/apps/resources/bundled_files/1-klass-10-ichinde-kemituu-oyun-1234.pptx
@@ -3781,7 +3781,7 @@
                 </a:solidFill>
                 <a:latin typeface="PT Sans"/>
               </a:rPr>
-              <a:t>1-класс ›</a:t>
+              <a:t/>
             </a:r>
           </a:p>
           <a:p>
@@ -4689,7 +4689,7 @@
                 </a:solidFill>
                 <a:latin typeface="PT Sans"/>
               </a:rPr>
-              <a:t>1-класс ›</a:t>
+              <a:t/>
             </a:r>
           </a:p>
           <a:p>
@@ -5631,7 +5631,7 @@
                 </a:solidFill>
                 <a:latin typeface="PT Sans"/>
               </a:rPr>
-              <a:t>1-класс ›</a:t>
+              <a:t/>
             </a:r>
           </a:p>
           <a:p>
@@ -6801,7 +6801,7 @@
                 </a:solidFill>
                 <a:latin typeface="PT Sans"/>
               </a:rPr>
-              <a:t>1-класс ›</a:t>
+              <a:t/>
             </a:r>
           </a:p>
           <a:p>
@@ -7743,7 +7743,7 @@
                 </a:solidFill>
                 <a:latin typeface="PT Sans"/>
               </a:rPr>
-              <a:t>1-класс ›</a:t>
+              <a:t/>
             </a:r>
           </a:p>
           <a:p>
@@ -8913,7 +8913,7 @@
                 </a:solidFill>
                 <a:latin typeface="PT Sans"/>
               </a:rPr>
-              <a:t>1-класс ›</a:t>
+              <a:t/>
             </a:r>
           </a:p>
           <a:p>
@@ -9855,7 +9855,7 @@
                 </a:solidFill>
                 <a:latin typeface="PT Sans"/>
               </a:rPr>
-              <a:t>1-класс ›</a:t>
+              <a:t/>
             </a:r>
           </a:p>
           <a:p>
@@ -11025,7 +11025,7 @@
                 </a:solidFill>
                 <a:latin typeface="PT Sans"/>
               </a:rPr>
-              <a:t>1-класс ›</a:t>
+              <a:t/>
             </a:r>
           </a:p>
           <a:p>
@@ -11967,7 +11967,7 @@
                 </a:solidFill>
                 <a:latin typeface="PT Sans"/>
               </a:rPr>
-              <a:t>1-класс ›</a:t>
+              <a:t/>
             </a:r>
           </a:p>
           <a:p>

</xml_diff>